<commit_message>
refactor(audit): replace markdown with official formatted xlsx workbook
</commit_message>
<xml_diff>
--- a/auditoria/Auditoria_Nutricional_Excelencia_Gabi.pptx
+++ b/auditoria/Auditoria_Nutricional_Excelencia_Gabi.pptx
@@ -5,13 +5,13 @@
     <p:sldMasterId id="2147483648" r:id="rId1"/>
   </p:sldMasterIdLst>
   <p:sldIdLst>
-    <p:sldId id="256" r:id="rId7"/>
-    <p:sldId id="257" r:id="rId8"/>
-    <p:sldId id="258" r:id="rId9"/>
-    <p:sldId id="259" r:id="rId10"/>
-    <p:sldId id="260" r:id="rId11"/>
+    <p:sldId id="256" r:id="rId2"/>
+    <p:sldId id="257" r:id="rId3"/>
+    <p:sldId id="258" r:id="rId4"/>
+    <p:sldId id="259" r:id="rId5"/>
+    <p:sldId id="260" r:id="rId6"/>
   </p:sldIdLst>
-  <p:sldSz cx="12191695" cy="6858000" type="screen4x3"/>
+  <p:sldSz cx="12192000" cy="6858000"/>
   <p:notesSz cx="6858000" cy="9144000"/>
   <p:defaultTextStyle>
     <a:defPPr>
@@ -108,6 +108,22 @@
       </a:defRPr>
     </a:lvl9pPr>
   </p:defaultTextStyle>
+  <p:extLst>
+    <p:ext uri="{EFAFB233-063F-42B5-8137-9DF3F51BA10A}">
+      <p15:sldGuideLst xmlns:p15="http://schemas.microsoft.com/office/powerpoint/2012/main">
+        <p15:guide id="1" orient="horz" pos="2160">
+          <p15:clr>
+            <a:srgbClr val="A4A3A4"/>
+          </p15:clr>
+        </p15:guide>
+        <p15:guide id="2" pos="2880">
+          <p15:clr>
+            <a:srgbClr val="A4A3A4"/>
+          </p15:clr>
+        </p15:guide>
+      </p15:sldGuideLst>
+    </p:ext>
+  </p:extLst>
 </p:presentation>
 </file>
 
@@ -149,10 +165,9 @@
           <a:lstStyle/>
           <a:p>
             <a:r>
-              <a:rPr lang="en-US" smtClean="0"/>
+              <a:rPr lang="en-US"/>
               <a:t>Click to edit Master title style</a:t>
             </a:r>
-            <a:endParaRPr lang="en-US"/>
           </a:p>
         </p:txBody>
       </p:sp>
@@ -268,10 +283,9 @@
           </a:lstStyle>
           <a:p>
             <a:r>
-              <a:rPr lang="en-US" smtClean="0"/>
+              <a:rPr lang="en-US"/>
               <a:t>Click to edit Master subtitle style</a:t>
             </a:r>
-            <a:endParaRPr lang="en-US"/>
           </a:p>
         </p:txBody>
       </p:sp>
@@ -292,7 +306,7 @@
           <a:p>
             <a:fld id="{5BCAD085-E8A6-8845-BD4E-CB4CCA059FC4}" type="datetimeFigureOut">
               <a:rPr lang="en-US" smtClean="0"/>
-              <a:t>1/27/13</a:t>
+              <a:t>9/14/2026</a:t>
             </a:fld>
             <a:endParaRPr lang="en-US"/>
           </a:p>
@@ -386,10 +400,9 @@
           <a:lstStyle/>
           <a:p>
             <a:r>
-              <a:rPr lang="en-US" smtClean="0"/>
+              <a:rPr lang="en-US"/>
               <a:t>Click to edit Master title style</a:t>
             </a:r>
-            <a:endParaRPr lang="en-US"/>
           </a:p>
         </p:txBody>
       </p:sp>
@@ -410,38 +423,37 @@
           <a:p>
             <a:pPr lvl="0"/>
             <a:r>
-              <a:rPr lang="en-US" smtClean="0"/>
+              <a:rPr lang="en-US"/>
               <a:t>Click to edit Master text styles</a:t>
             </a:r>
           </a:p>
           <a:p>
             <a:pPr lvl="1"/>
             <a:r>
-              <a:rPr lang="en-US" smtClean="0"/>
+              <a:rPr lang="en-US"/>
               <a:t>Second level</a:t>
             </a:r>
           </a:p>
           <a:p>
             <a:pPr lvl="2"/>
             <a:r>
-              <a:rPr lang="en-US" smtClean="0"/>
+              <a:rPr lang="en-US"/>
               <a:t>Third level</a:t>
             </a:r>
           </a:p>
           <a:p>
             <a:pPr lvl="3"/>
             <a:r>
-              <a:rPr lang="en-US" smtClean="0"/>
+              <a:rPr lang="en-US"/>
               <a:t>Fourth level</a:t>
             </a:r>
           </a:p>
           <a:p>
             <a:pPr lvl="4"/>
             <a:r>
-              <a:rPr lang="en-US" smtClean="0"/>
+              <a:rPr lang="en-US"/>
               <a:t>Fifth level</a:t>
             </a:r>
-            <a:endParaRPr lang="en-US"/>
           </a:p>
         </p:txBody>
       </p:sp>
@@ -462,7 +474,7 @@
           <a:p>
             <a:fld id="{5BCAD085-E8A6-8845-BD4E-CB4CCA059FC4}" type="datetimeFigureOut">
               <a:rPr lang="en-US" smtClean="0"/>
-              <a:t>1/27/13</a:t>
+              <a:t>9/14/2026</a:t>
             </a:fld>
             <a:endParaRPr lang="en-US"/>
           </a:p>
@@ -561,10 +573,9 @@
           <a:lstStyle/>
           <a:p>
             <a:r>
-              <a:rPr lang="en-US" smtClean="0"/>
+              <a:rPr lang="en-US"/>
               <a:t>Click to edit Master title style</a:t>
             </a:r>
-            <a:endParaRPr lang="en-US"/>
           </a:p>
         </p:txBody>
       </p:sp>
@@ -590,38 +601,37 @@
           <a:p>
             <a:pPr lvl="0"/>
             <a:r>
-              <a:rPr lang="en-US" smtClean="0"/>
+              <a:rPr lang="en-US"/>
               <a:t>Click to edit Master text styles</a:t>
             </a:r>
           </a:p>
           <a:p>
             <a:pPr lvl="1"/>
             <a:r>
-              <a:rPr lang="en-US" smtClean="0"/>
+              <a:rPr lang="en-US"/>
               <a:t>Second level</a:t>
             </a:r>
           </a:p>
           <a:p>
             <a:pPr lvl="2"/>
             <a:r>
-              <a:rPr lang="en-US" smtClean="0"/>
+              <a:rPr lang="en-US"/>
               <a:t>Third level</a:t>
             </a:r>
           </a:p>
           <a:p>
             <a:pPr lvl="3"/>
             <a:r>
-              <a:rPr lang="en-US" smtClean="0"/>
+              <a:rPr lang="en-US"/>
               <a:t>Fourth level</a:t>
             </a:r>
           </a:p>
           <a:p>
             <a:pPr lvl="4"/>
             <a:r>
-              <a:rPr lang="en-US" smtClean="0"/>
+              <a:rPr lang="en-US"/>
               <a:t>Fifth level</a:t>
             </a:r>
-            <a:endParaRPr lang="en-US"/>
           </a:p>
         </p:txBody>
       </p:sp>
@@ -642,7 +652,7 @@
           <a:p>
             <a:fld id="{5BCAD085-E8A6-8845-BD4E-CB4CCA059FC4}" type="datetimeFigureOut">
               <a:rPr lang="en-US" smtClean="0"/>
-              <a:t>1/27/13</a:t>
+              <a:t>9/14/2026</a:t>
             </a:fld>
             <a:endParaRPr lang="en-US"/>
           </a:p>
@@ -736,10 +746,9 @@
           <a:lstStyle/>
           <a:p>
             <a:r>
-              <a:rPr lang="en-US" smtClean="0"/>
+              <a:rPr lang="en-US"/>
               <a:t>Click to edit Master title style</a:t>
             </a:r>
-            <a:endParaRPr lang="en-US"/>
           </a:p>
         </p:txBody>
       </p:sp>
@@ -760,38 +769,37 @@
           <a:p>
             <a:pPr lvl="0"/>
             <a:r>
-              <a:rPr lang="en-US" smtClean="0"/>
+              <a:rPr lang="en-US"/>
               <a:t>Click to edit Master text styles</a:t>
             </a:r>
           </a:p>
           <a:p>
             <a:pPr lvl="1"/>
             <a:r>
-              <a:rPr lang="en-US" smtClean="0"/>
+              <a:rPr lang="en-US"/>
               <a:t>Second level</a:t>
             </a:r>
           </a:p>
           <a:p>
             <a:pPr lvl="2"/>
             <a:r>
-              <a:rPr lang="en-US" smtClean="0"/>
+              <a:rPr lang="en-US"/>
               <a:t>Third level</a:t>
             </a:r>
           </a:p>
           <a:p>
             <a:pPr lvl="3"/>
             <a:r>
-              <a:rPr lang="en-US" smtClean="0"/>
+              <a:rPr lang="en-US"/>
               <a:t>Fourth level</a:t>
             </a:r>
           </a:p>
           <a:p>
             <a:pPr lvl="4"/>
             <a:r>
-              <a:rPr lang="en-US" smtClean="0"/>
+              <a:rPr lang="en-US"/>
               <a:t>Fifth level</a:t>
             </a:r>
-            <a:endParaRPr lang="en-US"/>
           </a:p>
         </p:txBody>
       </p:sp>
@@ -812,7 +820,7 @@
           <a:p>
             <a:fld id="{5BCAD085-E8A6-8845-BD4E-CB4CCA059FC4}" type="datetimeFigureOut">
               <a:rPr lang="en-US" smtClean="0"/>
-              <a:t>1/27/13</a:t>
+              <a:t>9/14/2026</a:t>
             </a:fld>
             <a:endParaRPr lang="en-US"/>
           </a:p>
@@ -915,10 +923,9 @@
           </a:lstStyle>
           <a:p>
             <a:r>
-              <a:rPr lang="en-US" smtClean="0"/>
+              <a:rPr lang="en-US"/>
               <a:t>Click to edit Master title style</a:t>
             </a:r>
-            <a:endParaRPr lang="en-US"/>
           </a:p>
         </p:txBody>
       </p:sp>
@@ -1035,7 +1042,7 @@
           <a:p>
             <a:pPr lvl="0"/>
             <a:r>
-              <a:rPr lang="en-US" smtClean="0"/>
+              <a:rPr lang="en-US"/>
               <a:t>Click to edit Master text styles</a:t>
             </a:r>
           </a:p>
@@ -1058,7 +1065,7 @@
           <a:p>
             <a:fld id="{5BCAD085-E8A6-8845-BD4E-CB4CCA059FC4}" type="datetimeFigureOut">
               <a:rPr lang="en-US" smtClean="0"/>
-              <a:t>1/27/13</a:t>
+              <a:t>9/14/2026</a:t>
             </a:fld>
             <a:endParaRPr lang="en-US"/>
           </a:p>
@@ -1152,10 +1159,9 @@
           <a:lstStyle/>
           <a:p>
             <a:r>
-              <a:rPr lang="en-US" smtClean="0"/>
+              <a:rPr lang="en-US"/>
               <a:t>Click to edit Master title style</a:t>
             </a:r>
-            <a:endParaRPr lang="en-US"/>
           </a:p>
         </p:txBody>
       </p:sp>
@@ -1209,38 +1215,37 @@
           <a:p>
             <a:pPr lvl="0"/>
             <a:r>
-              <a:rPr lang="en-US" smtClean="0"/>
+              <a:rPr lang="en-US"/>
               <a:t>Click to edit Master text styles</a:t>
             </a:r>
           </a:p>
           <a:p>
             <a:pPr lvl="1"/>
             <a:r>
-              <a:rPr lang="en-US" smtClean="0"/>
+              <a:rPr lang="en-US"/>
               <a:t>Second level</a:t>
             </a:r>
           </a:p>
           <a:p>
             <a:pPr lvl="2"/>
             <a:r>
-              <a:rPr lang="en-US" smtClean="0"/>
+              <a:rPr lang="en-US"/>
               <a:t>Third level</a:t>
             </a:r>
           </a:p>
           <a:p>
             <a:pPr lvl="3"/>
             <a:r>
-              <a:rPr lang="en-US" smtClean="0"/>
+              <a:rPr lang="en-US"/>
               <a:t>Fourth level</a:t>
             </a:r>
           </a:p>
           <a:p>
             <a:pPr lvl="4"/>
             <a:r>
-              <a:rPr lang="en-US" smtClean="0"/>
+              <a:rPr lang="en-US"/>
               <a:t>Fifth level</a:t>
             </a:r>
-            <a:endParaRPr lang="en-US"/>
           </a:p>
         </p:txBody>
       </p:sp>
@@ -1294,38 +1299,37 @@
           <a:p>
             <a:pPr lvl="0"/>
             <a:r>
-              <a:rPr lang="en-US" smtClean="0"/>
+              <a:rPr lang="en-US"/>
               <a:t>Click to edit Master text styles</a:t>
             </a:r>
           </a:p>
           <a:p>
             <a:pPr lvl="1"/>
             <a:r>
-              <a:rPr lang="en-US" smtClean="0"/>
+              <a:rPr lang="en-US"/>
               <a:t>Second level</a:t>
             </a:r>
           </a:p>
           <a:p>
             <a:pPr lvl="2"/>
             <a:r>
-              <a:rPr lang="en-US" smtClean="0"/>
+              <a:rPr lang="en-US"/>
               <a:t>Third level</a:t>
             </a:r>
           </a:p>
           <a:p>
             <a:pPr lvl="3"/>
             <a:r>
-              <a:rPr lang="en-US" smtClean="0"/>
+              <a:rPr lang="en-US"/>
               <a:t>Fourth level</a:t>
             </a:r>
           </a:p>
           <a:p>
             <a:pPr lvl="4"/>
             <a:r>
-              <a:rPr lang="en-US" smtClean="0"/>
+              <a:rPr lang="en-US"/>
               <a:t>Fifth level</a:t>
             </a:r>
-            <a:endParaRPr lang="en-US"/>
           </a:p>
         </p:txBody>
       </p:sp>
@@ -1346,7 +1350,7 @@
           <a:p>
             <a:fld id="{5BCAD085-E8A6-8845-BD4E-CB4CCA059FC4}" type="datetimeFigureOut">
               <a:rPr lang="en-US" smtClean="0"/>
-              <a:t>1/27/13</a:t>
+              <a:t>9/14/2026</a:t>
             </a:fld>
             <a:endParaRPr lang="en-US"/>
           </a:p>
@@ -1444,10 +1448,9 @@
           </a:lstStyle>
           <a:p>
             <a:r>
-              <a:rPr lang="en-US" smtClean="0"/>
+              <a:rPr lang="en-US"/>
               <a:t>Click to edit Master title style</a:t>
             </a:r>
-            <a:endParaRPr lang="en-US"/>
           </a:p>
         </p:txBody>
       </p:sp>
@@ -1510,7 +1513,7 @@
           <a:p>
             <a:pPr lvl="0"/>
             <a:r>
-              <a:rPr lang="en-US" smtClean="0"/>
+              <a:rPr lang="en-US"/>
               <a:t>Click to edit Master text styles</a:t>
             </a:r>
           </a:p>
@@ -1566,38 +1569,37 @@
           <a:p>
             <a:pPr lvl="0"/>
             <a:r>
-              <a:rPr lang="en-US" smtClean="0"/>
+              <a:rPr lang="en-US"/>
               <a:t>Click to edit Master text styles</a:t>
             </a:r>
           </a:p>
           <a:p>
             <a:pPr lvl="1"/>
             <a:r>
-              <a:rPr lang="en-US" smtClean="0"/>
+              <a:rPr lang="en-US"/>
               <a:t>Second level</a:t>
             </a:r>
           </a:p>
           <a:p>
             <a:pPr lvl="2"/>
             <a:r>
-              <a:rPr lang="en-US" smtClean="0"/>
+              <a:rPr lang="en-US"/>
               <a:t>Third level</a:t>
             </a:r>
           </a:p>
           <a:p>
             <a:pPr lvl="3"/>
             <a:r>
-              <a:rPr lang="en-US" smtClean="0"/>
+              <a:rPr lang="en-US"/>
               <a:t>Fourth level</a:t>
             </a:r>
           </a:p>
           <a:p>
             <a:pPr lvl="4"/>
             <a:r>
-              <a:rPr lang="en-US" smtClean="0"/>
+              <a:rPr lang="en-US"/>
               <a:t>Fifth level</a:t>
             </a:r>
-            <a:endParaRPr lang="en-US"/>
           </a:p>
         </p:txBody>
       </p:sp>
@@ -1660,7 +1662,7 @@
           <a:p>
             <a:pPr lvl="0"/>
             <a:r>
-              <a:rPr lang="en-US" smtClean="0"/>
+              <a:rPr lang="en-US"/>
               <a:t>Click to edit Master text styles</a:t>
             </a:r>
           </a:p>
@@ -1716,38 +1718,37 @@
           <a:p>
             <a:pPr lvl="0"/>
             <a:r>
-              <a:rPr lang="en-US" smtClean="0"/>
+              <a:rPr lang="en-US"/>
               <a:t>Click to edit Master text styles</a:t>
             </a:r>
           </a:p>
           <a:p>
             <a:pPr lvl="1"/>
             <a:r>
-              <a:rPr lang="en-US" smtClean="0"/>
+              <a:rPr lang="en-US"/>
               <a:t>Second level</a:t>
             </a:r>
           </a:p>
           <a:p>
             <a:pPr lvl="2"/>
             <a:r>
-              <a:rPr lang="en-US" smtClean="0"/>
+              <a:rPr lang="en-US"/>
               <a:t>Third level</a:t>
             </a:r>
           </a:p>
           <a:p>
             <a:pPr lvl="3"/>
             <a:r>
-              <a:rPr lang="en-US" smtClean="0"/>
+              <a:rPr lang="en-US"/>
               <a:t>Fourth level</a:t>
             </a:r>
           </a:p>
           <a:p>
             <a:pPr lvl="4"/>
             <a:r>
-              <a:rPr lang="en-US" smtClean="0"/>
+              <a:rPr lang="en-US"/>
               <a:t>Fifth level</a:t>
             </a:r>
-            <a:endParaRPr lang="en-US"/>
           </a:p>
         </p:txBody>
       </p:sp>
@@ -1768,7 +1769,7 @@
           <a:p>
             <a:fld id="{5BCAD085-E8A6-8845-BD4E-CB4CCA059FC4}" type="datetimeFigureOut">
               <a:rPr lang="en-US" smtClean="0"/>
-              <a:t>1/27/13</a:t>
+              <a:t>9/14/2026</a:t>
             </a:fld>
             <a:endParaRPr lang="en-US"/>
           </a:p>
@@ -1862,10 +1863,9 @@
           <a:lstStyle/>
           <a:p>
             <a:r>
-              <a:rPr lang="en-US" smtClean="0"/>
+              <a:rPr lang="en-US"/>
               <a:t>Click to edit Master title style</a:t>
             </a:r>
-            <a:endParaRPr lang="en-US"/>
           </a:p>
         </p:txBody>
       </p:sp>
@@ -1886,7 +1886,7 @@
           <a:p>
             <a:fld id="{5BCAD085-E8A6-8845-BD4E-CB4CCA059FC4}" type="datetimeFigureOut">
               <a:rPr lang="en-US" smtClean="0"/>
-              <a:t>1/27/13</a:t>
+              <a:t>9/14/2026</a:t>
             </a:fld>
             <a:endParaRPr lang="en-US"/>
           </a:p>
@@ -1981,7 +1981,7 @@
           <a:p>
             <a:fld id="{5BCAD085-E8A6-8845-BD4E-CB4CCA059FC4}" type="datetimeFigureOut">
               <a:rPr lang="en-US" smtClean="0"/>
-              <a:t>1/27/13</a:t>
+              <a:t>9/14/2026</a:t>
             </a:fld>
             <a:endParaRPr lang="en-US"/>
           </a:p>
@@ -2084,10 +2084,9 @@
           </a:lstStyle>
           <a:p>
             <a:r>
-              <a:rPr lang="en-US" smtClean="0"/>
+              <a:rPr lang="en-US"/>
               <a:t>Click to edit Master title style</a:t>
             </a:r>
-            <a:endParaRPr lang="en-US"/>
           </a:p>
         </p:txBody>
       </p:sp>
@@ -2141,38 +2140,37 @@
           <a:p>
             <a:pPr lvl="0"/>
             <a:r>
-              <a:rPr lang="en-US" smtClean="0"/>
+              <a:rPr lang="en-US"/>
               <a:t>Click to edit Master text styles</a:t>
             </a:r>
           </a:p>
           <a:p>
             <a:pPr lvl="1"/>
             <a:r>
-              <a:rPr lang="en-US" smtClean="0"/>
+              <a:rPr lang="en-US"/>
               <a:t>Second level</a:t>
             </a:r>
           </a:p>
           <a:p>
             <a:pPr lvl="2"/>
             <a:r>
-              <a:rPr lang="en-US" smtClean="0"/>
+              <a:rPr lang="en-US"/>
               <a:t>Third level</a:t>
             </a:r>
           </a:p>
           <a:p>
             <a:pPr lvl="3"/>
             <a:r>
-              <a:rPr lang="en-US" smtClean="0"/>
+              <a:rPr lang="en-US"/>
               <a:t>Fourth level</a:t>
             </a:r>
           </a:p>
           <a:p>
             <a:pPr lvl="4"/>
             <a:r>
-              <a:rPr lang="en-US" smtClean="0"/>
+              <a:rPr lang="en-US"/>
               <a:t>Fifth level</a:t>
             </a:r>
-            <a:endParaRPr lang="en-US"/>
           </a:p>
         </p:txBody>
       </p:sp>
@@ -2235,7 +2233,7 @@
           <a:p>
             <a:pPr lvl="0"/>
             <a:r>
-              <a:rPr lang="en-US" smtClean="0"/>
+              <a:rPr lang="en-US"/>
               <a:t>Click to edit Master text styles</a:t>
             </a:r>
           </a:p>
@@ -2258,7 +2256,7 @@
           <a:p>
             <a:fld id="{5BCAD085-E8A6-8845-BD4E-CB4CCA059FC4}" type="datetimeFigureOut">
               <a:rPr lang="en-US" smtClean="0"/>
-              <a:t>1/27/13</a:t>
+              <a:t>9/14/2026</a:t>
             </a:fld>
             <a:endParaRPr lang="en-US"/>
           </a:p>
@@ -2361,10 +2359,9 @@
           </a:lstStyle>
           <a:p>
             <a:r>
-              <a:rPr lang="en-US" smtClean="0"/>
+              <a:rPr lang="en-US"/>
               <a:t>Click to edit Master title style</a:t>
             </a:r>
-            <a:endParaRPr lang="en-US"/>
           </a:p>
         </p:txBody>
       </p:sp>
@@ -2488,7 +2485,7 @@
           <a:p>
             <a:pPr lvl="0"/>
             <a:r>
-              <a:rPr lang="en-US" smtClean="0"/>
+              <a:rPr lang="en-US"/>
               <a:t>Click to edit Master text styles</a:t>
             </a:r>
           </a:p>
@@ -2511,7 +2508,7 @@
           <a:p>
             <a:fld id="{5BCAD085-E8A6-8845-BD4E-CB4CCA059FC4}" type="datetimeFigureOut">
               <a:rPr lang="en-US" smtClean="0"/>
-              <a:t>1/27/13</a:t>
+              <a:t>9/14/2026</a:t>
             </a:fld>
             <a:endParaRPr lang="en-US"/>
           </a:p>
@@ -2620,10 +2617,9 @@
           <a:lstStyle/>
           <a:p>
             <a:r>
-              <a:rPr lang="en-US" smtClean="0"/>
+              <a:rPr lang="en-US"/>
               <a:t>Click to edit Master title style</a:t>
             </a:r>
-            <a:endParaRPr lang="en-US"/>
           </a:p>
         </p:txBody>
       </p:sp>
@@ -2654,38 +2650,37 @@
           <a:p>
             <a:pPr lvl="0"/>
             <a:r>
-              <a:rPr lang="en-US" smtClean="0"/>
+              <a:rPr lang="en-US"/>
               <a:t>Click to edit Master text styles</a:t>
             </a:r>
           </a:p>
           <a:p>
             <a:pPr lvl="1"/>
             <a:r>
-              <a:rPr lang="en-US" smtClean="0"/>
+              <a:rPr lang="en-US"/>
               <a:t>Second level</a:t>
             </a:r>
           </a:p>
           <a:p>
             <a:pPr lvl="2"/>
             <a:r>
-              <a:rPr lang="en-US" smtClean="0"/>
+              <a:rPr lang="en-US"/>
               <a:t>Third level</a:t>
             </a:r>
           </a:p>
           <a:p>
             <a:pPr lvl="3"/>
             <a:r>
-              <a:rPr lang="en-US" smtClean="0"/>
+              <a:rPr lang="en-US"/>
               <a:t>Fourth level</a:t>
             </a:r>
           </a:p>
           <a:p>
             <a:pPr lvl="4"/>
             <a:r>
-              <a:rPr lang="en-US" smtClean="0"/>
+              <a:rPr lang="en-US"/>
               <a:t>Fifth level</a:t>
             </a:r>
-            <a:endParaRPr lang="en-US"/>
           </a:p>
         </p:txBody>
       </p:sp>
@@ -2724,7 +2719,7 @@
           <a:p>
             <a:fld id="{5BCAD085-E8A6-8845-BD4E-CB4CCA059FC4}" type="datetimeFigureOut">
               <a:rPr lang="en-US" smtClean="0"/>
-              <a:t>1/27/13</a:t>
+              <a:t>9/14/2026</a:t>
             </a:fld>
             <a:endParaRPr lang="en-US"/>
           </a:p>
@@ -3083,7 +3078,7 @@
 </file>
 
 <file path=ppt/slides/slide1.xml><?xml version="1.0" encoding="utf-8"?>
-<p:sld xmlns:a="http://schemas.openxmlformats.org/drawingml/2006/main" xmlns:p="http://schemas.openxmlformats.org/presentationml/2006/main" xmlns:r="http://schemas.openxmlformats.org/officeDocument/2006/relationships">
+<p:sld xmlns:a="http://schemas.openxmlformats.org/drawingml/2006/main" xmlns:r="http://schemas.openxmlformats.org/officeDocument/2006/relationships" xmlns:p="http://schemas.openxmlformats.org/presentationml/2006/main">
   <p:cSld>
     <p:spTree>
       <p:nvGrpSpPr>
@@ -3091,7 +3086,14 @@
         <p:cNvGrpSpPr/>
         <p:nvPr/>
       </p:nvGrpSpPr>
-      <p:grpSpPr/>
+      <p:grpSpPr>
+        <a:xfrm>
+          <a:off x="0" y="0"/>
+          <a:ext cx="0" cy="0"/>
+          <a:chOff x="0" y="0"/>
+          <a:chExt cx="0" cy="0"/>
+        </a:xfrm>
+      </p:grpSpPr>
       <p:sp>
         <p:nvSpPr>
           <p:cNvPr id="2" name="Rectangle 1"/>
@@ -3132,6 +3134,7 @@
           <a:lstStyle/>
           <a:p>
             <a:pPr algn="ctr"/>
+            <a:endParaRPr/>
           </a:p>
         </p:txBody>
       </p:sp>
@@ -3144,7 +3147,7 @@
         <p:spPr>
           <a:xfrm>
             <a:off x="914400" y="1828800"/>
-            <a:ext cx="10362895" cy="3200400"/>
+            <a:ext cx="8901283" cy="2062103"/>
           </a:xfrm>
           <a:prstGeom prst="rect">
             <a:avLst/>
@@ -3165,10 +3168,14 @@
               </a:defRPr>
             </a:pPr>
             <a:r>
+              <a:rPr dirty="0"/>
               <a:t>AUDITORIA HIGIÊNICO-SANITÁRIA &amp;</a:t>
             </a:r>
-            <a:br/>
-            <a:r>
+            <a:br>
+              <a:rPr dirty="0"/>
+            </a:br>
+            <a:r>
+              <a:rPr dirty="0"/>
               <a:t>EXCELÊNCIA EM UNIDADES DE ALIMENTAÇÃO</a:t>
             </a:r>
           </a:p>
@@ -3181,21 +3188,171 @@
               </a:defRPr>
             </a:pPr>
             <a:r>
-              <a:t>Da RDC 216 e Portaria CVS 5/SP ao Padrão Ouro 3 Estrelas Michelin</a:t>
-            </a:r>
-          </a:p>
-          <a:p>
-            <a:br/>
-            <a:pPr>
-              <a:defRPr sz="1400">
-                <a:solidFill>
-                  <a:srgbClr val="64748B"/>
-                </a:solidFill>
-              </a:defRPr>
-            </a:pPr>
-            <a:r>
-              <a:t>Curso de Graduação em Nutrição • Apresentação Acadêmica &amp; Prática Profissional</a:t>
-            </a:r>
+              <a:rPr dirty="0"/>
+              <a:t>Da RDC 216 e </a:t>
+            </a:r>
+            <a:r>
+              <a:rPr dirty="0" err="1"/>
+              <a:t>Portaria</a:t>
+            </a:r>
+            <a:r>
+              <a:rPr dirty="0"/>
+              <a:t> CVS 5/SP </a:t>
+            </a:r>
+            <a:r>
+              <a:rPr dirty="0" err="1"/>
+              <a:t>ao</a:t>
+            </a:r>
+            <a:r>
+              <a:rPr dirty="0"/>
+              <a:t> </a:t>
+            </a:r>
+            <a:r>
+              <a:rPr dirty="0" err="1"/>
+              <a:t>Padrão</a:t>
+            </a:r>
+            <a:r>
+              <a:rPr dirty="0"/>
+              <a:t> Ouro 3 </a:t>
+            </a:r>
+            <a:r>
+              <a:rPr dirty="0" err="1"/>
+              <a:t>Estrelas</a:t>
+            </a:r>
+            <a:r>
+              <a:rPr dirty="0"/>
+              <a:t> Michelin</a:t>
+            </a:r>
+          </a:p>
+          <a:p>
+            <a:br>
+              <a:rPr dirty="0"/>
+            </a:br>
+            <a:r>
+              <a:rPr dirty="0" err="1">
+                <a:solidFill>
+                  <a:schemeClr val="bg1"/>
+                </a:solidFill>
+              </a:rPr>
+              <a:t>Curso</a:t>
+            </a:r>
+            <a:r>
+              <a:rPr dirty="0">
+                <a:solidFill>
+                  <a:schemeClr val="bg1"/>
+                </a:solidFill>
+              </a:rPr>
+              <a:t> de </a:t>
+            </a:r>
+            <a:r>
+              <a:rPr dirty="0" err="1">
+                <a:solidFill>
+                  <a:schemeClr val="bg1"/>
+                </a:solidFill>
+              </a:rPr>
+              <a:t>Graduação</a:t>
+            </a:r>
+            <a:r>
+              <a:rPr dirty="0">
+                <a:solidFill>
+                  <a:schemeClr val="bg1"/>
+                </a:solidFill>
+              </a:rPr>
+              <a:t> </a:t>
+            </a:r>
+            <a:r>
+              <a:rPr dirty="0" err="1">
+                <a:solidFill>
+                  <a:schemeClr val="bg1"/>
+                </a:solidFill>
+              </a:rPr>
+              <a:t>em</a:t>
+            </a:r>
+            <a:r>
+              <a:rPr dirty="0">
+                <a:solidFill>
+                  <a:schemeClr val="bg1"/>
+                </a:solidFill>
+              </a:rPr>
+              <a:t> </a:t>
+            </a:r>
+            <a:r>
+              <a:rPr dirty="0" err="1">
+                <a:solidFill>
+                  <a:schemeClr val="bg1"/>
+                </a:solidFill>
+              </a:rPr>
+              <a:t>Nutrição</a:t>
+            </a:r>
+            <a:r>
+              <a:rPr dirty="0">
+                <a:solidFill>
+                  <a:schemeClr val="bg1"/>
+                </a:solidFill>
+              </a:rPr>
+              <a:t> • </a:t>
+            </a:r>
+            <a:r>
+              <a:rPr dirty="0" err="1">
+                <a:solidFill>
+                  <a:schemeClr val="bg1"/>
+                </a:solidFill>
+              </a:rPr>
+              <a:t>Apresentação</a:t>
+            </a:r>
+            <a:r>
+              <a:rPr dirty="0">
+                <a:solidFill>
+                  <a:schemeClr val="bg1"/>
+                </a:solidFill>
+              </a:rPr>
+              <a:t> </a:t>
+            </a:r>
+            <a:r>
+              <a:rPr dirty="0" err="1">
+                <a:solidFill>
+                  <a:schemeClr val="bg1"/>
+                </a:solidFill>
+              </a:rPr>
+              <a:t>Acadêmica</a:t>
+            </a:r>
+            <a:r>
+              <a:rPr dirty="0">
+                <a:solidFill>
+                  <a:schemeClr val="bg1"/>
+                </a:solidFill>
+              </a:rPr>
+              <a:t> &amp; </a:t>
+            </a:r>
+            <a:r>
+              <a:rPr dirty="0" err="1">
+                <a:solidFill>
+                  <a:schemeClr val="bg1"/>
+                </a:solidFill>
+              </a:rPr>
+              <a:t>Prática</a:t>
+            </a:r>
+            <a:r>
+              <a:rPr dirty="0">
+                <a:solidFill>
+                  <a:schemeClr val="bg1"/>
+                </a:solidFill>
+              </a:rPr>
+              <a:t> </a:t>
+            </a:r>
+            <a:r>
+              <a:rPr dirty="0" err="1">
+                <a:solidFill>
+                  <a:schemeClr val="bg1"/>
+                </a:solidFill>
+              </a:rPr>
+              <a:t>Profissional</a:t>
+            </a:r>
+            <a:endParaRPr dirty="0">
+              <a:solidFill>
+                <a:schemeClr val="bg1"/>
+              </a:solidFill>
+            </a:endParaRPr>
           </a:p>
         </p:txBody>
       </p:sp>
@@ -3208,7 +3365,7 @@
 </file>
 
 <file path=ppt/slides/slide2.xml><?xml version="1.0" encoding="utf-8"?>
-<p:sld xmlns:a="http://schemas.openxmlformats.org/drawingml/2006/main" xmlns:p="http://schemas.openxmlformats.org/presentationml/2006/main" xmlns:r="http://schemas.openxmlformats.org/officeDocument/2006/relationships">
+<p:sld xmlns:a="http://schemas.openxmlformats.org/drawingml/2006/main" xmlns:r="http://schemas.openxmlformats.org/officeDocument/2006/relationships" xmlns:p="http://schemas.openxmlformats.org/presentationml/2006/main">
   <p:cSld>
     <p:spTree>
       <p:nvGrpSpPr>
@@ -3216,7 +3373,14 @@
         <p:cNvGrpSpPr/>
         <p:nvPr/>
       </p:nvGrpSpPr>
-      <p:grpSpPr/>
+      <p:grpSpPr>
+        <a:xfrm>
+          <a:off x="0" y="0"/>
+          <a:ext cx="0" cy="0"/>
+          <a:chOff x="0" y="0"/>
+          <a:chExt cx="0" cy="0"/>
+        </a:xfrm>
+      </p:grpSpPr>
       <p:sp>
         <p:nvSpPr>
           <p:cNvPr id="2" name="Rectangle 1"/>
@@ -3253,7 +3417,7 @@
           </a:fontRef>
         </p:style>
         <p:txBody>
-          <a:bodyPr rtlCol="0" anchor="ctr" lIns="731520" tIns="182880"/>
+          <a:bodyPr lIns="731520" tIns="182880" rtlCol="0" anchor="ctr"/>
           <a:lstStyle/>
           <a:p>
             <a:pPr algn="ctr">
@@ -3319,11 +3483,11 @@
           </a:fontRef>
         </p:style>
         <p:txBody>
-          <a:bodyPr rtlCol="0" anchor="ctr" lIns="274320" rIns="274320"/>
+          <a:bodyPr lIns="274320" rIns="274320" rtlCol="0" anchor="ctr"/>
           <a:lstStyle/>
           <a:p>
             <a:pPr algn="ctr">
-              <a:defRPr b="1" sz="1600">
+              <a:defRPr sz="1600" b="1">
                 <a:solidFill>
                   <a:srgbClr val="0F172A"/>
                 </a:solidFill>
@@ -3339,13 +3503,6 @@
           </a:p>
           <a:p>
             <a:br/>
-            <a:pPr>
-              <a:defRPr sz="1200">
-                <a:solidFill>
-                  <a:srgbClr val="0F172A"/>
-                </a:solidFill>
-              </a:defRPr>
-            </a:pPr>
             <a:r>
               <a:t>• Regulamento Técnico de Boas Práticas para Serviços de Alimentação em todo o Brasil.</a:t>
             </a:r>
@@ -3398,11 +3555,11 @@
           </a:fontRef>
         </p:style>
         <p:txBody>
-          <a:bodyPr rtlCol="0" anchor="ctr" lIns="274320" rIns="274320"/>
+          <a:bodyPr lIns="274320" rIns="274320" rtlCol="0" anchor="ctr"/>
           <a:lstStyle/>
           <a:p>
             <a:pPr algn="ctr">
-              <a:defRPr b="1" sz="1600">
+              <a:defRPr sz="1600" b="1">
                 <a:solidFill>
                   <a:srgbClr val="0F172A"/>
                 </a:solidFill>
@@ -3418,13 +3575,6 @@
           </a:p>
           <a:p>
             <a:br/>
-            <a:pPr>
-              <a:defRPr sz="1200">
-                <a:solidFill>
-                  <a:srgbClr val="0F172A"/>
-                </a:solidFill>
-              </a:defRPr>
-            </a:pPr>
             <a:r>
               <a:t>• Centro de Vigilância Sanitária de SP.</a:t>
             </a:r>
@@ -3481,11 +3631,11 @@
           </a:fontRef>
         </p:style>
         <p:txBody>
-          <a:bodyPr rtlCol="0" anchor="ctr" lIns="274320" rIns="274320"/>
+          <a:bodyPr lIns="274320" rIns="274320" rtlCol="0" anchor="ctr"/>
           <a:lstStyle/>
           <a:p>
             <a:pPr algn="ctr">
-              <a:defRPr b="1" sz="1600">
+              <a:defRPr sz="1600" b="1">
                 <a:solidFill>
                   <a:srgbClr val="0F172A"/>
                 </a:solidFill>
@@ -3501,13 +3651,6 @@
           </a:p>
           <a:p>
             <a:br/>
-            <a:pPr>
-              <a:defRPr sz="1200">
-                <a:solidFill>
-                  <a:srgbClr val="0F172A"/>
-                </a:solidFill>
-              </a:defRPr>
-            </a:pPr>
             <a:r>
               <a:t>• Secretaria Municipal de Saúde de SP.</a:t>
             </a:r>
@@ -3535,7 +3678,7 @@
 </file>
 
 <file path=ppt/slides/slide3.xml><?xml version="1.0" encoding="utf-8"?>
-<p:sld xmlns:a="http://schemas.openxmlformats.org/drawingml/2006/main" xmlns:p="http://schemas.openxmlformats.org/presentationml/2006/main" xmlns:r="http://schemas.openxmlformats.org/officeDocument/2006/relationships">
+<p:sld xmlns:a="http://schemas.openxmlformats.org/drawingml/2006/main" xmlns:r="http://schemas.openxmlformats.org/officeDocument/2006/relationships" xmlns:p="http://schemas.openxmlformats.org/presentationml/2006/main">
   <p:cSld>
     <p:spTree>
       <p:nvGrpSpPr>
@@ -3543,7 +3686,14 @@
         <p:cNvGrpSpPr/>
         <p:nvPr/>
       </p:nvGrpSpPr>
-      <p:grpSpPr/>
+      <p:grpSpPr>
+        <a:xfrm>
+          <a:off x="0" y="0"/>
+          <a:ext cx="0" cy="0"/>
+          <a:chOff x="0" y="0"/>
+          <a:chExt cx="0" cy="0"/>
+        </a:xfrm>
+      </p:grpSpPr>
       <p:sp>
         <p:nvSpPr>
           <p:cNvPr id="2" name="Rectangle 1"/>
@@ -3580,7 +3730,7 @@
           </a:fontRef>
         </p:style>
         <p:txBody>
-          <a:bodyPr rtlCol="0" anchor="ctr" lIns="731520" tIns="182880"/>
+          <a:bodyPr lIns="731520" tIns="182880" rtlCol="0" anchor="ctr"/>
           <a:lstStyle/>
           <a:p>
             <a:pPr algn="ctr">
@@ -3646,11 +3796,11 @@
           </a:fontRef>
         </p:style>
         <p:txBody>
-          <a:bodyPr rtlCol="0" anchor="ctr" lIns="274320"/>
+          <a:bodyPr lIns="274320" rtlCol="0" anchor="ctr"/>
           <a:lstStyle/>
           <a:p>
             <a:pPr algn="ctr">
-              <a:defRPr b="1" sz="1400">
+              <a:defRPr sz="1400" b="1">
                 <a:solidFill>
                   <a:srgbClr val="0F172A"/>
                 </a:solidFill>
@@ -3712,11 +3862,11 @@
           </a:fontRef>
         </p:style>
         <p:txBody>
-          <a:bodyPr rtlCol="0" anchor="ctr" lIns="274320"/>
+          <a:bodyPr lIns="274320" rtlCol="0" anchor="ctr"/>
           <a:lstStyle/>
           <a:p>
             <a:pPr algn="ctr">
-              <a:defRPr b="1" sz="1400">
+              <a:defRPr sz="1400" b="1">
                 <a:solidFill>
                   <a:srgbClr val="0F172A"/>
                 </a:solidFill>
@@ -3778,11 +3928,11 @@
           </a:fontRef>
         </p:style>
         <p:txBody>
-          <a:bodyPr rtlCol="0" anchor="ctr" lIns="274320"/>
+          <a:bodyPr lIns="274320" rtlCol="0" anchor="ctr"/>
           <a:lstStyle/>
           <a:p>
             <a:pPr algn="ctr">
-              <a:defRPr b="1" sz="1400">
+              <a:defRPr sz="1400" b="1">
                 <a:solidFill>
                   <a:srgbClr val="0F172A"/>
                 </a:solidFill>
@@ -3844,11 +3994,11 @@
           </a:fontRef>
         </p:style>
         <p:txBody>
-          <a:bodyPr rtlCol="0" anchor="ctr" lIns="274320"/>
+          <a:bodyPr lIns="274320" rtlCol="0" anchor="ctr"/>
           <a:lstStyle/>
           <a:p>
             <a:pPr algn="ctr">
-              <a:defRPr b="1" sz="1400">
+              <a:defRPr sz="1400" b="1">
                 <a:solidFill>
                   <a:srgbClr val="0F172A"/>
                 </a:solidFill>
@@ -3910,11 +4060,11 @@
           </a:fontRef>
         </p:style>
         <p:txBody>
-          <a:bodyPr rtlCol="0" anchor="ctr" lIns="274320"/>
+          <a:bodyPr lIns="274320" rtlCol="0" anchor="ctr"/>
           <a:lstStyle/>
           <a:p>
             <a:pPr algn="ctr">
-              <a:defRPr b="1" sz="1400">
+              <a:defRPr sz="1400" b="1">
                 <a:solidFill>
                   <a:srgbClr val="0F172A"/>
                 </a:solidFill>
@@ -3947,7 +4097,7 @@
 </file>
 
 <file path=ppt/slides/slide4.xml><?xml version="1.0" encoding="utf-8"?>
-<p:sld xmlns:a="http://schemas.openxmlformats.org/drawingml/2006/main" xmlns:p="http://schemas.openxmlformats.org/presentationml/2006/main" xmlns:r="http://schemas.openxmlformats.org/officeDocument/2006/relationships">
+<p:sld xmlns:a="http://schemas.openxmlformats.org/drawingml/2006/main" xmlns:r="http://schemas.openxmlformats.org/officeDocument/2006/relationships" xmlns:p="http://schemas.openxmlformats.org/presentationml/2006/main">
   <p:cSld>
     <p:spTree>
       <p:nvGrpSpPr>
@@ -3955,7 +4105,14 @@
         <p:cNvGrpSpPr/>
         <p:nvPr/>
       </p:nvGrpSpPr>
-      <p:grpSpPr/>
+      <p:grpSpPr>
+        <a:xfrm>
+          <a:off x="0" y="0"/>
+          <a:ext cx="0" cy="0"/>
+          <a:chOff x="0" y="0"/>
+          <a:chExt cx="0" cy="0"/>
+        </a:xfrm>
+      </p:grpSpPr>
       <p:sp>
         <p:nvSpPr>
           <p:cNvPr id="2" name="Rectangle 1"/>
@@ -3992,7 +4149,7 @@
           </a:fontRef>
         </p:style>
         <p:txBody>
-          <a:bodyPr rtlCol="0" anchor="ctr" lIns="731520" tIns="182880"/>
+          <a:bodyPr lIns="731520" tIns="182880" rtlCol="0" anchor="ctr"/>
           <a:lstStyle/>
           <a:p>
             <a:pPr algn="ctr">
@@ -4058,11 +4215,11 @@
           </a:fontRef>
         </p:style>
         <p:txBody>
-          <a:bodyPr rtlCol="0" anchor="ctr" lIns="182880" rIns="182880"/>
+          <a:bodyPr lIns="182880" rIns="182880" rtlCol="0" anchor="ctr"/>
           <a:lstStyle/>
           <a:p>
             <a:pPr algn="ctr">
-              <a:defRPr b="1" sz="1300">
+              <a:defRPr sz="1300" b="1">
                 <a:solidFill>
                   <a:srgbClr val="0F172A"/>
                 </a:solidFill>
@@ -4074,13 +4231,6 @@
           </a:p>
           <a:p>
             <a:br/>
-            <a:pPr>
-              <a:defRPr sz="1050">
-                <a:solidFill>
-                  <a:srgbClr val="64748B"/>
-                </a:solidFill>
-              </a:defRPr>
-            </a:pPr>
             <a:r>
               <a:t>Sem cruzamento de cru x cozido; rodapés côncavos; pias com pedal.</a:t>
             </a:r>
@@ -4125,11 +4275,11 @@
           </a:fontRef>
         </p:style>
         <p:txBody>
-          <a:bodyPr rtlCol="0" anchor="ctr" lIns="182880" rIns="182880"/>
+          <a:bodyPr lIns="182880" rIns="182880" rtlCol="0" anchor="ctr"/>
           <a:lstStyle/>
           <a:p>
             <a:pPr algn="ctr">
-              <a:defRPr b="1" sz="1300">
+              <a:defRPr sz="1300" b="1">
                 <a:solidFill>
                   <a:srgbClr val="0F172A"/>
                 </a:solidFill>
@@ -4141,13 +4291,6 @@
           </a:p>
           <a:p>
             <a:br/>
-            <a:pPr>
-              <a:defRPr sz="1050">
-                <a:solidFill>
-                  <a:srgbClr val="64748B"/>
-                </a:solidFill>
-              </a:defRPr>
-            </a:pPr>
             <a:r>
               <a:t>Limpeza semestral de caixa d'água com laudo; caixa de gordura externa.</a:t>
             </a:r>
@@ -4192,11 +4335,11 @@
           </a:fontRef>
         </p:style>
         <p:txBody>
-          <a:bodyPr rtlCol="0" anchor="ctr" lIns="182880" rIns="182880"/>
+          <a:bodyPr lIns="182880" rIns="182880" rtlCol="0" anchor="ctr"/>
           <a:lstStyle/>
           <a:p>
             <a:pPr algn="ctr">
-              <a:defRPr b="1" sz="1300">
+              <a:defRPr sz="1300" b="1">
                 <a:solidFill>
                   <a:srgbClr val="0F172A"/>
                 </a:solidFill>
@@ -4208,13 +4351,6 @@
           </a:p>
           <a:p>
             <a:br/>
-            <a:pPr>
-              <a:defRPr sz="1050">
-                <a:solidFill>
-                  <a:srgbClr val="64748B"/>
-                </a:solidFill>
-              </a:defRPr>
-            </a:pPr>
             <a:r>
               <a:t>Empresa licenciada; mapa de iscas numeradas; barreira física e ralos sifonados.</a:t>
             </a:r>
@@ -4259,11 +4395,11 @@
           </a:fontRef>
         </p:style>
         <p:txBody>
-          <a:bodyPr rtlCol="0" anchor="ctr" lIns="182880" rIns="182880"/>
+          <a:bodyPr lIns="182880" rIns="182880" rtlCol="0" anchor="ctr"/>
           <a:lstStyle/>
           <a:p>
             <a:pPr algn="ctr">
-              <a:defRPr b="1" sz="1300">
+              <a:defRPr sz="1300" b="1">
                 <a:solidFill>
                   <a:srgbClr val="0F172A"/>
                 </a:solidFill>
@@ -4275,13 +4411,6 @@
           </a:p>
           <a:p>
             <a:br/>
-            <a:pPr>
-              <a:defRPr sz="1050">
-                <a:solidFill>
-                  <a:srgbClr val="64748B"/>
-                </a:solidFill>
-              </a:defRPr>
-            </a:pPr>
             <a:r>
               <a:t>Critérios de aceite térmico (pescado &lt;= 2°C; carnes &lt;= 7°C); SIF/SISP.</a:t>
             </a:r>
@@ -4326,11 +4455,11 @@
           </a:fontRef>
         </p:style>
         <p:txBody>
-          <a:bodyPr rtlCol="0" anchor="ctr" lIns="182880" rIns="182880"/>
+          <a:bodyPr lIns="182880" rIns="182880" rtlCol="0" anchor="ctr"/>
           <a:lstStyle/>
           <a:p>
             <a:pPr algn="ctr">
-              <a:defRPr b="1" sz="1300">
+              <a:defRPr sz="1300" b="1">
                 <a:solidFill>
                   <a:srgbClr val="0F172A"/>
                 </a:solidFill>
@@ -4342,13 +4471,6 @@
           </a:p>
           <a:p>
             <a:br/>
-            <a:pPr>
-              <a:defRPr sz="1050">
-                <a:solidFill>
-                  <a:srgbClr val="64748B"/>
-                </a:solidFill>
-              </a:defRPr>
-            </a:pPr>
             <a:r>
               <a:t>Etiquetagem completa; Primeiro que Vence, Primeiro que Sai; câmaras 0°C a 4°C.</a:t>
             </a:r>
@@ -4393,11 +4515,11 @@
           </a:fontRef>
         </p:style>
         <p:txBody>
-          <a:bodyPr rtlCol="0" anchor="ctr" lIns="182880" rIns="182880"/>
+          <a:bodyPr lIns="182880" rIns="182880" rtlCol="0" anchor="ctr"/>
           <a:lstStyle/>
           <a:p>
             <a:pPr algn="ctr">
-              <a:defRPr b="1" sz="1300">
+              <a:defRPr sz="1300" b="1">
                 <a:solidFill>
                   <a:srgbClr val="0F172A"/>
                 </a:solidFill>
@@ -4409,13 +4531,6 @@
           </a:p>
           <a:p>
             <a:br/>
-            <a:pPr>
-              <a:defRPr sz="1050">
-                <a:solidFill>
-                  <a:srgbClr val="64748B"/>
-                </a:solidFill>
-              </a:defRPr>
-            </a:pPr>
             <a:r>
               <a:t>Cocção &gt; 70°C no centro geométrico; resfriamento rápido em menos de 2h.</a:t>
             </a:r>
@@ -4460,11 +4575,11 @@
           </a:fontRef>
         </p:style>
         <p:txBody>
-          <a:bodyPr rtlCol="0" anchor="ctr" lIns="182880" rIns="182880"/>
+          <a:bodyPr lIns="182880" rIns="182880" rtlCol="0" anchor="ctr"/>
           <a:lstStyle/>
           <a:p>
             <a:pPr algn="ctr">
-              <a:defRPr b="1" sz="1300">
+              <a:defRPr sz="1300" b="1">
                 <a:solidFill>
                   <a:srgbClr val="0F172A"/>
                 </a:solidFill>
@@ -4476,13 +4591,6 @@
           </a:p>
           <a:p>
             <a:br/>
-            <a:pPr>
-              <a:defRPr sz="1050">
-                <a:solidFill>
-                  <a:srgbClr val="64748B"/>
-                </a:solidFill>
-              </a:defRPr>
-            </a:pPr>
             <a:r>
               <a:t>Lavagem mecânica -&gt; Imersão clorada 100-250 ppm por 15 min -&gt; Enxágue.</a:t>
             </a:r>
@@ -4527,11 +4635,11 @@
           </a:fontRef>
         </p:style>
         <p:txBody>
-          <a:bodyPr rtlCol="0" anchor="ctr" lIns="182880" rIns="182880"/>
+          <a:bodyPr lIns="182880" rIns="182880" rtlCol="0" anchor="ctr"/>
           <a:lstStyle/>
           <a:p>
             <a:pPr algn="ctr">
-              <a:defRPr b="1" sz="1300">
+              <a:defRPr sz="1300" b="1">
                 <a:solidFill>
                   <a:srgbClr val="0F172A"/>
                 </a:solidFill>
@@ -4543,13 +4651,6 @@
           </a:p>
           <a:p>
             <a:br/>
-            <a:pPr>
-              <a:defRPr sz="1050">
-                <a:solidFill>
-                  <a:srgbClr val="64748B"/>
-                </a:solidFill>
-              </a:defRPr>
-            </a:pPr>
             <a:r>
               <a:t>Uniformes claros e íntegros; zero adornos; ASO e exames parasitológicos válidos.</a:t>
             </a:r>
@@ -4594,11 +4695,11 @@
           </a:fontRef>
         </p:style>
         <p:txBody>
-          <a:bodyPr rtlCol="0" anchor="ctr" lIns="182880" rIns="182880"/>
+          <a:bodyPr lIns="182880" rIns="182880" rtlCol="0" anchor="ctr"/>
           <a:lstStyle/>
           <a:p>
             <a:pPr algn="ctr">
-              <a:defRPr b="1" sz="1300">
+              <a:defRPr sz="1300" b="1">
                 <a:solidFill>
                   <a:srgbClr val="0F172A"/>
                 </a:solidFill>
@@ -4610,13 +4711,6 @@
           </a:p>
           <a:p>
             <a:br/>
-            <a:pPr>
-              <a:defRPr sz="1050">
-                <a:solidFill>
-                  <a:srgbClr val="64748B"/>
-                </a:solidFill>
-              </a:defRPr>
-            </a:pPr>
             <a:r>
               <a:t>MBP e 6 POPs atualizados; guarda de amostras de 100g por 72h obrigatória em SP.</a:t>
             </a:r>
@@ -4632,7 +4726,7 @@
 </file>
 
 <file path=ppt/slides/slide5.xml><?xml version="1.0" encoding="utf-8"?>
-<p:sld xmlns:a="http://schemas.openxmlformats.org/drawingml/2006/main" xmlns:p="http://schemas.openxmlformats.org/presentationml/2006/main" xmlns:r="http://schemas.openxmlformats.org/officeDocument/2006/relationships">
+<p:sld xmlns:a="http://schemas.openxmlformats.org/drawingml/2006/main" xmlns:r="http://schemas.openxmlformats.org/officeDocument/2006/relationships" xmlns:p="http://schemas.openxmlformats.org/presentationml/2006/main">
   <p:cSld>
     <p:spTree>
       <p:nvGrpSpPr>
@@ -4640,7 +4734,14 @@
         <p:cNvGrpSpPr/>
         <p:nvPr/>
       </p:nvGrpSpPr>
-      <p:grpSpPr/>
+      <p:grpSpPr>
+        <a:xfrm>
+          <a:off x="0" y="0"/>
+          <a:ext cx="0" cy="0"/>
+          <a:chOff x="0" y="0"/>
+          <a:chExt cx="0" cy="0"/>
+        </a:xfrm>
+      </p:grpSpPr>
       <p:sp>
         <p:nvSpPr>
           <p:cNvPr id="2" name="Rectangle 1"/>
@@ -4677,7 +4778,7 @@
           </a:fontRef>
         </p:style>
         <p:txBody>
-          <a:bodyPr rtlCol="0" anchor="ctr" lIns="731520" tIns="182880"/>
+          <a:bodyPr lIns="731520" tIns="182880" rtlCol="0" anchor="ctr"/>
           <a:lstStyle/>
           <a:p>
             <a:pPr algn="ctr">
@@ -4688,6 +4789,7 @@
               </a:defRPr>
             </a:pPr>
             <a:r>
+              <a:rPr dirty="0"/>
               <a:t>4. DIGITALIZAÇÃO DA AUDITORIA // NUTRIPOCKET AUDIT ENGINE</a:t>
             </a:r>
           </a:p>
@@ -4700,7 +4802,52 @@
               </a:defRPr>
             </a:pPr>
             <a:r>
-              <a:t>Transformando pranchetas de papel em inteligência em tempo real</a:t>
+              <a:rPr dirty="0" err="1"/>
+              <a:t>Transformando</a:t>
+            </a:r>
+            <a:r>
+              <a:rPr dirty="0"/>
+              <a:t> </a:t>
+            </a:r>
+            <a:r>
+              <a:rPr dirty="0" err="1"/>
+              <a:t>pranchetas</a:t>
+            </a:r>
+            <a:r>
+              <a:rPr dirty="0"/>
+              <a:t> de </a:t>
+            </a:r>
+            <a:r>
+              <a:rPr dirty="0" err="1"/>
+              <a:t>papel</a:t>
+            </a:r>
+            <a:r>
+              <a:rPr dirty="0"/>
+              <a:t> </a:t>
+            </a:r>
+            <a:r>
+              <a:rPr dirty="0" err="1"/>
+              <a:t>em</a:t>
+            </a:r>
+            <a:r>
+              <a:rPr dirty="0"/>
+              <a:t> </a:t>
+            </a:r>
+            <a:r>
+              <a:rPr dirty="0" err="1"/>
+              <a:t>inteligência</a:t>
+            </a:r>
+            <a:r>
+              <a:rPr dirty="0"/>
+              <a:t> </a:t>
+            </a:r>
+            <a:r>
+              <a:rPr dirty="0" err="1"/>
+              <a:t>em</a:t>
+            </a:r>
+            <a:r>
+              <a:rPr dirty="0"/>
+              <a:t> tempo real</a:t>
             </a:r>
           </a:p>
         </p:txBody>
@@ -4743,22 +4890,173 @@
           </a:fontRef>
         </p:style>
         <p:txBody>
-          <a:bodyPr rtlCol="0" anchor="ctr" lIns="365760"/>
+          <a:bodyPr lIns="365760" rtlCol="0" anchor="ctr"/>
           <a:lstStyle/>
           <a:p>
             <a:pPr algn="ctr"/>
-          </a:p>
-          <a:p>
-            <a:br/>
+            <a:endParaRPr dirty="0"/>
+          </a:p>
+          <a:p>
+            <a:br>
+              <a:rPr dirty="0"/>
+            </a:br>
+            <a:r>
+              <a:rPr dirty="0"/>
+              <a:t>✔ 📱 Checklist Mobile-First no </a:t>
+            </a:r>
+            <a:r>
+              <a:rPr dirty="0" err="1"/>
+              <a:t>NutriPocket</a:t>
+            </a:r>
+            <a:endParaRPr dirty="0"/>
+          </a:p>
+          <a:p>
             <a:pPr>
-              <a:defRPr b="1" sz="1400">
-                <a:solidFill>
-                  <a:srgbClr val="0F172A"/>
+              <a:defRPr sz="1200">
+                <a:solidFill>
+                  <a:srgbClr val="64748B"/>
                 </a:solidFill>
               </a:defRPr>
             </a:pPr>
             <a:r>
-              <a:t>✔ 📱 Checklist Mobile-First no NutriPocket</a:t>
+              <a:rPr dirty="0"/>
+              <a:t>   O </a:t>
+            </a:r>
+            <a:r>
+              <a:rPr dirty="0" err="1"/>
+              <a:t>nutricionista</a:t>
+            </a:r>
+            <a:r>
+              <a:rPr dirty="0"/>
+              <a:t> </a:t>
+            </a:r>
+            <a:r>
+              <a:rPr dirty="0" err="1"/>
+              <a:t>audita</a:t>
+            </a:r>
+            <a:r>
+              <a:rPr dirty="0"/>
+              <a:t> a </a:t>
+            </a:r>
+            <a:r>
+              <a:rPr dirty="0" err="1"/>
+              <a:t>cozinha</a:t>
+            </a:r>
+            <a:r>
+              <a:rPr dirty="0"/>
+              <a:t> </a:t>
+            </a:r>
+            <a:r>
+              <a:rPr dirty="0" err="1"/>
+              <a:t>direto</a:t>
+            </a:r>
+            <a:r>
+              <a:rPr dirty="0"/>
+              <a:t> </a:t>
+            </a:r>
+            <a:r>
+              <a:rPr dirty="0" err="1"/>
+              <a:t>pelo</a:t>
+            </a:r>
+            <a:r>
+              <a:rPr dirty="0"/>
+              <a:t> </a:t>
+            </a:r>
+            <a:r>
+              <a:rPr dirty="0" err="1"/>
+              <a:t>celular</a:t>
+            </a:r>
+            <a:r>
+              <a:rPr dirty="0"/>
+              <a:t> </a:t>
+            </a:r>
+            <a:r>
+              <a:rPr dirty="0" err="1"/>
+              <a:t>ou</a:t>
+            </a:r>
+            <a:r>
+              <a:rPr dirty="0"/>
+              <a:t> tablet, </a:t>
+            </a:r>
+            <a:r>
+              <a:rPr dirty="0" err="1"/>
+              <a:t>marcando</a:t>
+            </a:r>
+            <a:r>
+              <a:rPr dirty="0"/>
+              <a:t> Conforme (C), </a:t>
+            </a:r>
+            <a:r>
+              <a:rPr dirty="0" err="1"/>
+              <a:t>Não</a:t>
+            </a:r>
+            <a:r>
+              <a:rPr dirty="0"/>
+              <a:t> Conforme (NC) e </a:t>
+            </a:r>
+            <a:r>
+              <a:rPr dirty="0" err="1"/>
+              <a:t>Não</a:t>
+            </a:r>
+            <a:r>
+              <a:rPr dirty="0"/>
+              <a:t> </a:t>
+            </a:r>
+            <a:r>
+              <a:rPr dirty="0" err="1"/>
+              <a:t>Aplicável</a:t>
+            </a:r>
+            <a:r>
+              <a:rPr dirty="0"/>
+              <a:t> (NA) com </a:t>
+            </a:r>
+            <a:r>
+              <a:rPr dirty="0" err="1"/>
+              <a:t>cálculo</a:t>
+            </a:r>
+            <a:r>
+              <a:rPr dirty="0"/>
+              <a:t> </a:t>
+            </a:r>
+            <a:r>
+              <a:rPr dirty="0" err="1"/>
+              <a:t>automático</a:t>
+            </a:r>
+            <a:r>
+              <a:rPr dirty="0"/>
+              <a:t> da Nota </a:t>
+            </a:r>
+            <a:r>
+              <a:rPr dirty="0" err="1"/>
+              <a:t>Sanitária</a:t>
+            </a:r>
+            <a:r>
+              <a:rPr dirty="0"/>
+              <a:t>.</a:t>
+            </a:r>
+          </a:p>
+          <a:p>
+            <a:br>
+              <a:rPr dirty="0"/>
+            </a:br>
+            <a:r>
+              <a:rPr dirty="0"/>
+              <a:t>✔ 📸 Registro </a:t>
+            </a:r>
+            <a:r>
+              <a:rPr dirty="0" err="1"/>
+              <a:t>Fotográfico</a:t>
+            </a:r>
+            <a:r>
+              <a:rPr dirty="0"/>
+              <a:t> </a:t>
+            </a:r>
+            <a:r>
+              <a:rPr dirty="0" err="1"/>
+              <a:t>Integrado</a:t>
+            </a:r>
+            <a:r>
+              <a:t> (Google Drive Cloud)</a:t>
             </a:r>
           </a:p>
           <a:p>
@@ -4770,21 +5068,298 @@
               </a:defRPr>
             </a:pPr>
             <a:r>
-              <a:t>   O nutricionista audita a cozinha direto pelo celular ou tablet, marcando Conforme (C), Não Conforme (NC) e Não Aplicável (NA) com cálculo automático da Nota Sanitária.</a:t>
-            </a:r>
-          </a:p>
-          <a:p>
-            <a:br/>
+              <a:rPr dirty="0"/>
+              <a:t>   </a:t>
+            </a:r>
+            <a:r>
+              <a:rPr dirty="0" err="1"/>
+              <a:t>Tirada</a:t>
+            </a:r>
+            <a:r>
+              <a:rPr dirty="0"/>
+              <a:t> de </a:t>
+            </a:r>
+            <a:r>
+              <a:rPr dirty="0" err="1"/>
+              <a:t>fotos</a:t>
+            </a:r>
+            <a:r>
+              <a:rPr dirty="0"/>
+              <a:t> de </a:t>
+            </a:r>
+            <a:r>
+              <a:rPr dirty="0" err="1"/>
+              <a:t>não-conformidades</a:t>
+            </a:r>
+            <a:r>
+              <a:rPr dirty="0"/>
+              <a:t> (ex: </a:t>
+            </a:r>
+            <a:r>
+              <a:rPr dirty="0" err="1"/>
+              <a:t>temperatura</a:t>
+            </a:r>
+            <a:r>
+              <a:rPr dirty="0"/>
+              <a:t> fora da </a:t>
+            </a:r>
+            <a:r>
+              <a:rPr dirty="0" err="1"/>
+              <a:t>faixa</a:t>
+            </a:r>
+            <a:r>
+              <a:rPr dirty="0"/>
+              <a:t>, </a:t>
+            </a:r>
+            <a:r>
+              <a:rPr dirty="0" err="1"/>
+              <a:t>alimento</a:t>
+            </a:r>
+            <a:r>
+              <a:rPr dirty="0"/>
+              <a:t> </a:t>
+            </a:r>
+            <a:r>
+              <a:rPr dirty="0" err="1"/>
+              <a:t>sem</a:t>
+            </a:r>
+            <a:r>
+              <a:rPr dirty="0"/>
+              <a:t> </a:t>
+            </a:r>
+            <a:r>
+              <a:rPr dirty="0" err="1"/>
+              <a:t>etiqueta</a:t>
+            </a:r>
+            <a:r>
+              <a:rPr dirty="0"/>
+              <a:t>) </a:t>
+            </a:r>
+            <a:r>
+              <a:rPr dirty="0" err="1"/>
+              <a:t>diretamente</a:t>
+            </a:r>
+            <a:r>
+              <a:rPr dirty="0"/>
+              <a:t> </a:t>
+            </a:r>
+            <a:r>
+              <a:rPr dirty="0" err="1"/>
+              <a:t>pelo</a:t>
+            </a:r>
+            <a:r>
+              <a:rPr dirty="0"/>
+              <a:t> app, com upload </a:t>
+            </a:r>
+            <a:r>
+              <a:rPr dirty="0" err="1"/>
+              <a:t>em</a:t>
+            </a:r>
+            <a:r>
+              <a:rPr dirty="0"/>
+              <a:t> </a:t>
+            </a:r>
+            <a:r>
+              <a:rPr dirty="0" err="1"/>
+              <a:t>nuvem</a:t>
+            </a:r>
+            <a:r>
+              <a:rPr dirty="0"/>
+              <a:t> e </a:t>
+            </a:r>
+            <a:r>
+              <a:rPr dirty="0" err="1"/>
+              <a:t>organização</a:t>
+            </a:r>
+            <a:r>
+              <a:rPr dirty="0"/>
+              <a:t> </a:t>
+            </a:r>
+            <a:r>
+              <a:rPr dirty="0" err="1"/>
+              <a:t>por</a:t>
+            </a:r>
+            <a:r>
+              <a:rPr dirty="0"/>
+              <a:t> </a:t>
+            </a:r>
+            <a:r>
+              <a:rPr dirty="0" err="1"/>
+              <a:t>setor</a:t>
+            </a:r>
+            <a:r>
+              <a:rPr dirty="0"/>
+              <a:t> da </a:t>
+            </a:r>
+            <a:r>
+              <a:rPr dirty="0" err="1"/>
+              <a:t>cozinha</a:t>
+            </a:r>
+            <a:r>
+              <a:rPr dirty="0"/>
+              <a:t>.</a:t>
+            </a:r>
+          </a:p>
+          <a:p>
+            <a:br>
+              <a:rPr dirty="0"/>
+            </a:br>
+            <a:r>
+              <a:rPr dirty="0"/>
+              <a:t>✔ 📄 </a:t>
+            </a:r>
+            <a:r>
+              <a:rPr dirty="0" err="1"/>
+              <a:t>Relatório</a:t>
+            </a:r>
+            <a:r>
+              <a:rPr dirty="0"/>
+              <a:t> </a:t>
+            </a:r>
+            <a:r>
+              <a:rPr dirty="0" err="1"/>
+              <a:t>Executivo</a:t>
+            </a:r>
+            <a:r>
+              <a:rPr dirty="0"/>
+              <a:t> </a:t>
+            </a:r>
+            <a:r>
+              <a:rPr dirty="0" err="1"/>
+              <a:t>Instantâneo</a:t>
+            </a:r>
+            <a:r>
+              <a:rPr dirty="0"/>
+              <a:t> </a:t>
+            </a:r>
+            <a:r>
+              <a:rPr dirty="0" err="1"/>
+              <a:t>em</a:t>
+            </a:r>
+            <a:r>
+              <a:rPr dirty="0"/>
+              <a:t> PDF / </a:t>
+            </a:r>
+            <a:r>
+              <a:rPr dirty="0" err="1"/>
+              <a:t>Compartilhamento</a:t>
+            </a:r>
+            <a:endParaRPr dirty="0"/>
+          </a:p>
+          <a:p>
             <a:pPr>
-              <a:defRPr b="1" sz="1400">
-                <a:solidFill>
-                  <a:srgbClr val="0F172A"/>
+              <a:defRPr sz="1200">
+                <a:solidFill>
+                  <a:srgbClr val="64748B"/>
                 </a:solidFill>
               </a:defRPr>
             </a:pPr>
             <a:r>
-              <a:t>✔ 📸 Registro Fotográfico Integrado (Google Drive Cloud)</a:t>
-            </a:r>
+              <a:rPr dirty="0"/>
+              <a:t>   </a:t>
+            </a:r>
+            <a:r>
+              <a:rPr dirty="0" err="1"/>
+              <a:t>Geração</a:t>
+            </a:r>
+            <a:r>
+              <a:rPr dirty="0"/>
+              <a:t> de </a:t>
+            </a:r>
+            <a:r>
+              <a:rPr dirty="0" err="1"/>
+              <a:t>relatório</a:t>
+            </a:r>
+            <a:r>
+              <a:rPr dirty="0"/>
+              <a:t> </a:t>
+            </a:r>
+            <a:r>
+              <a:rPr dirty="0" err="1"/>
+              <a:t>imediato</a:t>
+            </a:r>
+            <a:r>
+              <a:rPr dirty="0"/>
+              <a:t> com </a:t>
+            </a:r>
+            <a:r>
+              <a:rPr dirty="0" err="1"/>
+              <a:t>gráfico</a:t>
+            </a:r>
+            <a:r>
+              <a:rPr dirty="0"/>
+              <a:t> radar dos 9 </a:t>
+            </a:r>
+            <a:r>
+              <a:rPr dirty="0" err="1"/>
+              <a:t>pilares</a:t>
+            </a:r>
+            <a:r>
+              <a:rPr dirty="0"/>
+              <a:t> e plano de </a:t>
+            </a:r>
+            <a:r>
+              <a:rPr dirty="0" err="1"/>
+              <a:t>ação</a:t>
+            </a:r>
+            <a:r>
+              <a:rPr dirty="0"/>
+              <a:t> </a:t>
+            </a:r>
+            <a:r>
+              <a:rPr dirty="0" err="1"/>
+              <a:t>corretiva</a:t>
+            </a:r>
+            <a:r>
+              <a:rPr dirty="0"/>
+              <a:t> para o </a:t>
+            </a:r>
+            <a:r>
+              <a:rPr dirty="0" err="1"/>
+              <a:t>proprietário</a:t>
+            </a:r>
+            <a:r>
+              <a:rPr dirty="0"/>
+              <a:t> </a:t>
+            </a:r>
+            <a:r>
+              <a:rPr dirty="0" err="1"/>
+              <a:t>ou</a:t>
+            </a:r>
+            <a:r>
+              <a:rPr dirty="0"/>
+              <a:t> chef </a:t>
+            </a:r>
+            <a:r>
+              <a:rPr dirty="0" err="1"/>
+              <a:t>assinar</a:t>
+            </a:r>
+            <a:r>
+              <a:rPr dirty="0"/>
+              <a:t> </a:t>
+            </a:r>
+            <a:r>
+              <a:rPr dirty="0" err="1"/>
+              <a:t>na</a:t>
+            </a:r>
+            <a:r>
+              <a:rPr dirty="0"/>
+              <a:t> hora.</a:t>
+            </a:r>
+          </a:p>
+          <a:p>
+            <a:br>
+              <a:rPr dirty="0"/>
+            </a:br>
+            <a:r>
+              <a:rPr dirty="0"/>
+              <a:t>✔ 📊 Histórico &amp; Dashboard de </a:t>
+            </a:r>
+            <a:r>
+              <a:rPr dirty="0" err="1"/>
+              <a:t>Conformidade</a:t>
+            </a:r>
+            <a:endParaRPr dirty="0"/>
           </a:p>
           <a:p>
             <a:pPr>
@@ -4795,57 +5370,96 @@
               </a:defRPr>
             </a:pPr>
             <a:r>
-              <a:t>   Tirada de fotos de não-conformidades (ex: temperatura fora da faixa, alimento sem etiqueta) diretamente pelo app, com upload em nuvem e organização por setor da cozinha.</a:t>
-            </a:r>
-          </a:p>
-          <a:p>
-            <a:br/>
-            <a:pPr>
-              <a:defRPr b="1" sz="1400">
-                <a:solidFill>
-                  <a:srgbClr val="0F172A"/>
-                </a:solidFill>
-              </a:defRPr>
-            </a:pPr>
-            <a:r>
-              <a:t>✔ 📄 Relatório Executivo Instantâneo em PDF / Compartilhamento</a:t>
-            </a:r>
-          </a:p>
-          <a:p>
-            <a:pPr>
-              <a:defRPr sz="1200">
-                <a:solidFill>
-                  <a:srgbClr val="64748B"/>
-                </a:solidFill>
-              </a:defRPr>
-            </a:pPr>
-            <a:r>
-              <a:t>   Geração de relatório imediato com gráfico radar dos 9 pilares e plano de ação corretiva para o proprietário ou chef assinar na hora.</a:t>
-            </a:r>
-          </a:p>
-          <a:p>
-            <a:br/>
-            <a:pPr>
-              <a:defRPr b="1" sz="1400">
-                <a:solidFill>
-                  <a:srgbClr val="0F172A"/>
-                </a:solidFill>
-              </a:defRPr>
-            </a:pPr>
-            <a:r>
-              <a:t>✔ 📊 Histórico &amp; Dashboard de Conformidade</a:t>
-            </a:r>
-          </a:p>
-          <a:p>
-            <a:pPr>
-              <a:defRPr sz="1200">
-                <a:solidFill>
-                  <a:srgbClr val="64748B"/>
-                </a:solidFill>
-              </a:defRPr>
-            </a:pPr>
-            <a:r>
-              <a:t>   Acompanhamento da evolução sanitária ao longo das semanas, prevenindo multas e interdições da Vigilância Sanitária.</a:t>
+              <a:rPr dirty="0"/>
+              <a:t>   </a:t>
+            </a:r>
+            <a:r>
+              <a:rPr dirty="0" err="1"/>
+              <a:t>Acompanhamento</a:t>
+            </a:r>
+            <a:r>
+              <a:rPr dirty="0"/>
+              <a:t> da </a:t>
+            </a:r>
+            <a:r>
+              <a:rPr dirty="0" err="1"/>
+              <a:t>evolução</a:t>
+            </a:r>
+            <a:r>
+              <a:rPr dirty="0"/>
+              <a:t> </a:t>
+            </a:r>
+            <a:r>
+              <a:rPr dirty="0" err="1"/>
+              <a:t>sanitária</a:t>
+            </a:r>
+            <a:r>
+              <a:rPr dirty="0"/>
+              <a:t> </a:t>
+            </a:r>
+            <a:r>
+              <a:rPr dirty="0" err="1"/>
+              <a:t>ao</a:t>
+            </a:r>
+            <a:r>
+              <a:rPr dirty="0"/>
+              <a:t> </a:t>
+            </a:r>
+            <a:r>
+              <a:rPr dirty="0" err="1"/>
+              <a:t>longo</a:t>
+            </a:r>
+            <a:r>
+              <a:rPr dirty="0"/>
+              <a:t> das </a:t>
+            </a:r>
+            <a:r>
+              <a:rPr dirty="0" err="1"/>
+              <a:t>semanas</a:t>
+            </a:r>
+            <a:r>
+              <a:rPr dirty="0"/>
+              <a:t>, </a:t>
+            </a:r>
+            <a:r>
+              <a:rPr dirty="0" err="1"/>
+              <a:t>prevenindo</a:t>
+            </a:r>
+            <a:r>
+              <a:rPr dirty="0"/>
+              <a:t> </a:t>
+            </a:r>
+            <a:r>
+              <a:rPr dirty="0" err="1"/>
+              <a:t>multas</a:t>
+            </a:r>
+            <a:r>
+              <a:rPr dirty="0"/>
+              <a:t> e </a:t>
+            </a:r>
+            <a:r>
+              <a:rPr dirty="0" err="1"/>
+              <a:t>interdições</a:t>
+            </a:r>
+            <a:r>
+              <a:rPr dirty="0"/>
+              <a:t> da </a:t>
+            </a:r>
+            <a:r>
+              <a:rPr dirty="0" err="1"/>
+              <a:t>Vigilância</a:t>
+            </a:r>
+            <a:r>
+              <a:rPr dirty="0"/>
+              <a:t> </a:t>
+            </a:r>
+            <a:r>
+              <a:rPr dirty="0" err="1"/>
+              <a:t>Sanitária</a:t>
+            </a:r>
+            <a:r>
+              <a:rPr dirty="0"/>
+              <a:t>.</a:t>
             </a:r>
           </a:p>
         </p:txBody>

</xml_diff>